<commit_message>
feat(第28週): weekly report 07/06 ~ 07/12 - 138 records
</commit_message>
<xml_diff>
--- a/weekly-ppt/ecoco_週報_第23週_0601-0607.pptx
+++ b/weekly-ppt/ecoco_週報_第23週_0601-0607.pptx
@@ -1833,6 +1833,17 @@
             <a:pPr indent="0" marL="0">
               <a:buNone/>
             </a:pPr>
+            <a:r>
+              <a:rPr lang="en-US" sz="1050" b="1" dirty="0">
+                <a:solidFill>
+                  <a:srgbClr val="060E9F"/>
+                </a:solidFill>
+                <a:latin typeface="Noto Sans TC" pitchFamily="34" charset="0"/>
+                <a:ea typeface="Noto Sans TC" pitchFamily="34" charset="-122"/>
+                <a:cs typeface="Noto Sans TC" pitchFamily="34" charset="-120"/>
+              </a:rPr>
+              <a:t>客訴趨勢分析</a:t>
+            </a:r>
             <a:endParaRPr lang="en-US" sz="1050" dirty="0"/>
           </a:p>
         </p:txBody>
@@ -6169,7 +6180,7 @@
                 <a:ea typeface="Noto Sans TC" pitchFamily="34" charset="-122"/>
                 <a:cs typeface="Noto Sans TC" pitchFamily="34" charset="-120"/>
               </a:rPr>
-              <a:t>36件・13.1%</a:t>
+              <a:t>36件・21.4%</a:t>
             </a:r>
             <a:endParaRPr lang="en-US" sz="1800" dirty="0"/>
           </a:p>
@@ -6199,18 +6210,7 @@
             <a:pPr indent="0" marL="0">
               <a:buNone/>
             </a:pPr>
-            <a:r>
-              <a:rPr lang="en-US" sz="700" dirty="0">
-                <a:solidFill>
-                  <a:srgbClr val="888888"/>
-                </a:solidFill>
-                <a:latin typeface="Noto Sans TC" pitchFamily="34" charset="0"/>
-                <a:ea typeface="Noto Sans TC" pitchFamily="34" charset="-122"/>
-                <a:cs typeface="Noto Sans TC" pitchFamily="34" charset="-120"/>
-              </a:rPr>
-              <a:t>連三週持續高位，建議追蹤SMS服務商改善進度</a:t>
-            </a:r>
-            <a:endParaRPr lang="en-US" sz="700" dirty="0"/>
+            <a:endParaRPr lang="en-US" sz="600" dirty="0"/>
           </a:p>
         </p:txBody>
       </p:sp>
@@ -6243,7 +6243,7 @@
         <p:spPr>
           <a:xfrm>
             <a:off x="5833872" y="3387852"/>
-            <a:ext cx="421648" cy="45720"/>
+            <a:ext cx="688799" cy="45720"/>
           </a:xfrm>
           <a:prstGeom prst="rect">
             <a:avLst/>
@@ -6410,7 +6410,7 @@
                 <a:ea typeface="Noto Sans TC" pitchFamily="34" charset="-122"/>
                 <a:cs typeface="Noto Sans TC" pitchFamily="34" charset="-120"/>
               </a:rPr>
-              <a:t>19件・6.9%</a:t>
+              <a:t>19件・11.3%</a:t>
             </a:r>
             <a:endParaRPr lang="en-US" sz="1800" dirty="0"/>
           </a:p>
@@ -6440,18 +6440,7 @@
             <a:pPr indent="0" marL="0">
               <a:buNone/>
             </a:pPr>
-            <a:r>
-              <a:rPr lang="en-US" sz="700" dirty="0">
-                <a:solidFill>
-                  <a:srgbClr val="888888"/>
-                </a:solidFill>
-                <a:latin typeface="Noto Sans TC" pitchFamily="34" charset="0"/>
-                <a:ea typeface="Noto Sans TC" pitchFamily="34" charset="-122"/>
-                <a:cs typeface="Noto Sans TC" pitchFamily="34" charset="-120"/>
-              </a:rPr>
-              <a:t>收瓶機18件、方舟站1件</a:t>
-            </a:r>
-            <a:endParaRPr lang="en-US" sz="700" dirty="0"/>
+            <a:endParaRPr lang="en-US" sz="600" dirty="0"/>
           </a:p>
         </p:txBody>
       </p:sp>
@@ -6484,7 +6473,7 @@
         <p:spPr>
           <a:xfrm>
             <a:off x="5833872" y="4210812"/>
-            <a:ext cx="222089" cy="45720"/>
+            <a:ext cx="363712" cy="45720"/>
           </a:xfrm>
           <a:prstGeom prst="rect">
             <a:avLst/>
@@ -6612,7 +6601,7 @@
                 <a:ea typeface="Noto Sans TC" pitchFamily="34" charset="-122"/>
                 <a:cs typeface="Noto Sans TC" pitchFamily="34" charset="-120"/>
               </a:rPr>
-              <a:t>忘記密碼/無法重設</a:t>
+              <a:t>忘記密碼/無法重設密碼</a:t>
             </a:r>
             <a:endParaRPr lang="en-US" sz="1000" dirty="0"/>
           </a:p>
@@ -6651,7 +6640,7 @@
                 <a:ea typeface="Noto Sans TC" pitchFamily="34" charset="-122"/>
                 <a:cs typeface="Noto Sans TC" pitchFamily="34" charset="-120"/>
               </a:rPr>
-              <a:t>5件・1.8%</a:t>
+              <a:t>5件・3%</a:t>
             </a:r>
             <a:endParaRPr lang="en-US" sz="1800" dirty="0"/>
           </a:p>
@@ -6681,18 +6670,7 @@
             <a:pPr indent="0" marL="0">
               <a:buNone/>
             </a:pPr>
-            <a:r>
-              <a:rPr lang="en-US" sz="700" dirty="0">
-                <a:solidFill>
-                  <a:srgbClr val="888888"/>
-                </a:solidFill>
-                <a:latin typeface="Noto Sans TC" pitchFamily="34" charset="0"/>
-                <a:ea typeface="Noto Sans TC" pitchFamily="34" charset="-122"/>
-                <a:cs typeface="Noto Sans TC" pitchFamily="34" charset="-120"/>
-              </a:rPr>
-              <a:t>與簡訊驗證碼問題高度相關</a:t>
-            </a:r>
-            <a:endParaRPr lang="en-US" sz="700" dirty="0"/>
+            <a:endParaRPr lang="en-US" sz="600" dirty="0"/>
           </a:p>
         </p:txBody>
       </p:sp>
@@ -6725,7 +6703,7 @@
         <p:spPr>
           <a:xfrm>
             <a:off x="5833872" y="5033772"/>
-            <a:ext cx="57936" cy="45720"/>
+            <a:ext cx="96561" cy="45720"/>
           </a:xfrm>
           <a:prstGeom prst="rect">
             <a:avLst/>
@@ -6851,6 +6829,17 @@
             <a:pPr indent="0" marL="0">
               <a:buNone/>
             </a:pPr>
+            <a:r>
+              <a:rPr lang="en-US" sz="1050" b="1" dirty="0">
+                <a:solidFill>
+                  <a:srgbClr val="060E9F"/>
+                </a:solidFill>
+                <a:latin typeface="Noto Sans TC" pitchFamily="34" charset="0"/>
+                <a:ea typeface="Noto Sans TC" pitchFamily="34" charset="-122"/>
+                <a:cs typeface="Noto Sans TC" pitchFamily="34" charset="-120"/>
+              </a:rPr>
+              <a:t>客訴詳情與分類佔比</a:t>
+            </a:r>
             <a:endParaRPr lang="en-US" sz="1050" dirty="0"/>
           </a:p>
         </p:txBody>
@@ -8781,7 +8770,7 @@
                 <a:ea typeface="Noto Sans TC" pitchFamily="34" charset="-122"/>
                 <a:cs typeface="Noto Sans TC" pitchFamily="34" charset="-120"/>
               </a:rPr>
-              <a:t>【注意】瓶蓋桶已滿 連兩週居首｜本週29件（30.5%），較上週明顯上升。無法接收簡訊驗證碼持續高位36件，已連三週，建議追蹤SMS服務商改善進度。</a:t>
+              <a:t>【注意】無法接收簡訊驗證碼 持續高位｜本週36件（21.4%）。【注意】點數未入帳號 持續高位｜本週19件（11.3%）。收瓶機 瓶蓋桶已滿 29件（31.0%）居首，請確認清空頻率。</a:t>
             </a:r>
             <a:endParaRPr lang="en-US" sz="750" dirty="0"/>
           </a:p>
@@ -8918,7 +8907,7 @@
                 <a:ea typeface="Noto Sans TC" pitchFamily="34" charset="-122"/>
                 <a:cs typeface="Noto Sans TC" pitchFamily="34" charset="-120"/>
               </a:rPr>
-              <a:t>・全聯苓雅三多店站</a:t>
+              <a:t>・全聯福利中心苓雅三多店站</a:t>
             </a:r>
             <a:endParaRPr lang="en-US" sz="850" dirty="0"/>
           </a:p>
@@ -9074,7 +9063,7 @@
                 <a:ea typeface="Noto Sans TC" pitchFamily="34" charset="-122"/>
                 <a:cs typeface="Noto Sans TC" pitchFamily="34" charset="-120"/>
               </a:rPr>
-              <a:t>・小北百貨高雄大昌店站</a:t>
+              <a:t>・全聯福利中心高雄鳳林店站</a:t>
             </a:r>
             <a:endParaRPr lang="en-US" sz="850" dirty="0"/>
           </a:p>
@@ -9328,7 +9317,7 @@
                 <a:ea typeface="Noto Sans TC" pitchFamily="34" charset="-122"/>
                 <a:cs typeface="Noto Sans TC" pitchFamily="34" charset="-120"/>
               </a:rPr>
-              <a:t>・全聯蘆洲重陽店站</a:t>
+              <a:t>・全聯福利中心蘆洲重陽店站</a:t>
             </a:r>
             <a:endParaRPr lang="en-US" sz="850" dirty="0"/>
           </a:p>
@@ -9406,7 +9395,7 @@
                 <a:ea typeface="Noto Sans TC" pitchFamily="34" charset="-122"/>
                 <a:cs typeface="Noto Sans TC" pitchFamily="34" charset="-120"/>
               </a:rPr>
-              <a:t>・全聯中和新生店站</a:t>
+              <a:t>・全聯福利中心中和新生店站</a:t>
             </a:r>
             <a:endParaRPr lang="en-US" sz="850" dirty="0"/>
           </a:p>
@@ -9504,7 +9493,7 @@
                 <a:ea typeface="Noto Sans TC" pitchFamily="34" charset="-122"/>
                 <a:cs typeface="Noto Sans TC" pitchFamily="34" charset="-120"/>
               </a:rPr>
-              <a:t>臺南</a:t>
+              <a:t>桃園</a:t>
             </a:r>
             <a:endParaRPr lang="en-US" sz="1200" dirty="0"/>
           </a:p>
@@ -9582,7 +9571,7 @@
                 <a:ea typeface="Noto Sans TC" pitchFamily="34" charset="-122"/>
                 <a:cs typeface="Noto Sans TC" pitchFamily="34" charset="-120"/>
               </a:rPr>
-              <a:t>・全家西港南海店站</a:t>
+              <a:t>・全聯福利中心平鎮上海店站</a:t>
             </a:r>
             <a:endParaRPr lang="en-US" sz="850" dirty="0"/>
           </a:p>
@@ -9597,6 +9586,84 @@
         <p:spPr>
           <a:xfrm>
             <a:off x="8412480" y="4315968"/>
+            <a:ext cx="548640" cy="201168"/>
+          </a:xfrm>
+          <a:prstGeom prst="rect">
+            <a:avLst/>
+          </a:prstGeom>
+          <a:noFill/>
+          <a:ln/>
+        </p:spPr>
+        <p:txBody>
+          <a:bodyPr wrap="square" rtlCol="0" anchor="ctr"/>
+          <a:lstStyle/>
+          <a:p>
+            <a:pPr algn="r" indent="0" marL="0">
+              <a:buNone/>
+            </a:pPr>
+            <a:r>
+              <a:rPr lang="en-US" sz="900" b="1" dirty="0">
+                <a:solidFill>
+                  <a:srgbClr val="888888"/>
+                </a:solidFill>
+                <a:latin typeface="Arial" pitchFamily="34" charset="0"/>
+                <a:ea typeface="Arial" pitchFamily="34" charset="-122"/>
+                <a:cs typeface="Arial" pitchFamily="34" charset="-120"/>
+              </a:rPr>
+              <a:t>2</a:t>
+            </a:r>
+            <a:endParaRPr lang="en-US" sz="900" dirty="0"/>
+          </a:p>
+        </p:txBody>
+      </p:sp>
+      <p:sp>
+        <p:nvSpPr>
+          <p:cNvPr id="89" name="Text 86"/>
+          <p:cNvSpPr/>
+          <p:nvPr/>
+        </p:nvSpPr>
+        <p:spPr>
+          <a:xfrm>
+            <a:off x="5760720" y="4521708"/>
+            <a:ext cx="2560320" cy="201168"/>
+          </a:xfrm>
+          <a:prstGeom prst="rect">
+            <a:avLst/>
+          </a:prstGeom>
+          <a:noFill/>
+          <a:ln/>
+        </p:spPr>
+        <p:txBody>
+          <a:bodyPr wrap="square" rtlCol="0" anchor="ctr"/>
+          <a:lstStyle/>
+          <a:p>
+            <a:pPr indent="0" marL="0">
+              <a:buNone/>
+            </a:pPr>
+            <a:r>
+              <a:rPr lang="en-US" sz="850" dirty="0">
+                <a:solidFill>
+                  <a:srgbClr val="333333"/>
+                </a:solidFill>
+                <a:latin typeface="Noto Sans TC" pitchFamily="34" charset="0"/>
+                <a:ea typeface="Noto Sans TC" pitchFamily="34" charset="-122"/>
+                <a:cs typeface="Noto Sans TC" pitchFamily="34" charset="-120"/>
+              </a:rPr>
+              <a:t>・全聯福利中心大園春德店站</a:t>
+            </a:r>
+            <a:endParaRPr lang="en-US" sz="850" dirty="0"/>
+          </a:p>
+        </p:txBody>
+      </p:sp>
+      <p:sp>
+        <p:nvSpPr>
+          <p:cNvPr id="90" name="Text 87"/>
+          <p:cNvSpPr/>
+          <p:nvPr/>
+        </p:nvSpPr>
+        <p:spPr>
+          <a:xfrm>
+            <a:off x="8412480" y="4521708"/>
             <a:ext cx="548640" cy="201168"/>
           </a:xfrm>
           <a:prstGeom prst="rect">
@@ -9629,13 +9696,13 @@
       </p:sp>
       <p:sp>
         <p:nvSpPr>
-          <p:cNvPr id="89" name="Text 86"/>
-          <p:cNvSpPr/>
-          <p:nvPr/>
-        </p:nvSpPr>
-        <p:spPr>
-          <a:xfrm>
-            <a:off x="5760720" y="4521708"/>
+          <p:cNvPr id="91" name="Text 88"/>
+          <p:cNvSpPr/>
+          <p:nvPr/>
+        </p:nvSpPr>
+        <p:spPr>
+          <a:xfrm>
+            <a:off x="5760720" y="4727448"/>
             <a:ext cx="2560320" cy="201168"/>
           </a:xfrm>
           <a:prstGeom prst="rect">
@@ -9660,85 +9727,7 @@
                 <a:ea typeface="Noto Sans TC" pitchFamily="34" charset="-122"/>
                 <a:cs typeface="Noto Sans TC" pitchFamily="34" charset="-120"/>
               </a:rPr>
-              <a:t>・全家仁德新德店站</a:t>
-            </a:r>
-            <a:endParaRPr lang="en-US" sz="850" dirty="0"/>
-          </a:p>
-        </p:txBody>
-      </p:sp>
-      <p:sp>
-        <p:nvSpPr>
-          <p:cNvPr id="90" name="Text 87"/>
-          <p:cNvSpPr/>
-          <p:nvPr/>
-        </p:nvSpPr>
-        <p:spPr>
-          <a:xfrm>
-            <a:off x="8412480" y="4521708"/>
-            <a:ext cx="548640" cy="201168"/>
-          </a:xfrm>
-          <a:prstGeom prst="rect">
-            <a:avLst/>
-          </a:prstGeom>
-          <a:noFill/>
-          <a:ln/>
-        </p:spPr>
-        <p:txBody>
-          <a:bodyPr wrap="square" rtlCol="0" anchor="ctr"/>
-          <a:lstStyle/>
-          <a:p>
-            <a:pPr algn="r" indent="0" marL="0">
-              <a:buNone/>
-            </a:pPr>
-            <a:r>
-              <a:rPr lang="en-US" sz="900" b="1" dirty="0">
-                <a:solidFill>
-                  <a:srgbClr val="888888"/>
-                </a:solidFill>
-                <a:latin typeface="Arial" pitchFamily="34" charset="0"/>
-                <a:ea typeface="Arial" pitchFamily="34" charset="-122"/>
-                <a:cs typeface="Arial" pitchFamily="34" charset="-120"/>
-              </a:rPr>
-              <a:t>1</a:t>
-            </a:r>
-            <a:endParaRPr lang="en-US" sz="900" dirty="0"/>
-          </a:p>
-        </p:txBody>
-      </p:sp>
-      <p:sp>
-        <p:nvSpPr>
-          <p:cNvPr id="91" name="Text 88"/>
-          <p:cNvSpPr/>
-          <p:nvPr/>
-        </p:nvSpPr>
-        <p:spPr>
-          <a:xfrm>
-            <a:off x="5760720" y="4727448"/>
-            <a:ext cx="2560320" cy="201168"/>
-          </a:xfrm>
-          <a:prstGeom prst="rect">
-            <a:avLst/>
-          </a:prstGeom>
-          <a:noFill/>
-          <a:ln/>
-        </p:spPr>
-        <p:txBody>
-          <a:bodyPr wrap="square" rtlCol="0" anchor="ctr"/>
-          <a:lstStyle/>
-          <a:p>
-            <a:pPr indent="0" marL="0">
-              <a:buNone/>
-            </a:pPr>
-            <a:r>
-              <a:rPr lang="en-US" sz="850" dirty="0">
-                <a:solidFill>
-                  <a:srgbClr val="333333"/>
-                </a:solidFill>
-                <a:latin typeface="Noto Sans TC" pitchFamily="34" charset="0"/>
-                <a:ea typeface="Noto Sans TC" pitchFamily="34" charset="-122"/>
-                <a:cs typeface="Noto Sans TC" pitchFamily="34" charset="-120"/>
-              </a:rPr>
-              <a:t>・台南總圖方舟站</a:t>
+              <a:t>・全聯福利中心蘆竹興福店站</a:t>
             </a:r>
             <a:endParaRPr lang="en-US" sz="850" dirty="0"/>
           </a:p>

</xml_diff>